<commit_message>
fix: light slides only, no dark backgrounds (weak projectors)
White backgrounds throughout; code cards, demo strips, done cards, table
headers and icon circles switched from near-black to light, high-contrast fills.

Co-Authored-By: Claude Sonnet 5.5 <noreply@anthropic.com>
</commit_message>
<xml_diff>
--- a/deck/session3.pptx
+++ b/deck/session3.pptx
@@ -133,52 +133,52 @@
   <p:extLst>
     <p:ext uri="{521415D9-36F7-43E2-AB2F-B90AF26B5E84}">
       <p14:sectionLst xmlns:p14="http://schemas.microsoft.com/office/powerpoint/2010/main">
-        <p14:section name="Intro" id="{92057777-ad28-84dc-de7b-08d99f7d738e}">
+        <p14:section name="Intro" id="{98b8b102-dc32-0226-6968-a1fcf3e6e7ee}">
           <p14:sldIdLst>
             <p14:sldId id="256"/>
             <p14:sldId id="257"/>
           </p14:sldIdLst>
         </p14:section>
-        <p14:section name="Basic agent" id="{c586d007-8397-2ad5-001d-d7f9ac9338c5}">
+        <p14:section name="Basic agent" id="{6ecfb914-8d1b-2db4-d0b4-44706e6329ed}">
           <p14:sldIdLst>
             <p14:sldId id="258"/>
             <p14:sldId id="259"/>
             <p14:sldId id="260"/>
           </p14:sldIdLst>
         </p14:section>
-        <p14:section name="Agent patterns" id="{a343811f-51f8-9876-f1ce-50c6f0c3572f}">
+        <p14:section name="Agent patterns" id="{bbf9cc69-4c0c-4f4c-7d41-1b2934b0f64a}">
           <p14:sldIdLst>
             <p14:sldId id="261"/>
             <p14:sldId id="262"/>
           </p14:sldIdLst>
         </p14:section>
-        <p14:section name="MCP" id="{2bb9ce99-eded-5355-ffb0-301bfdd5181c}">
+        <p14:section name="MCP" id="{fafd5139-c200-849f-6904-94b12174d6af}">
           <p14:sldIdLst>
             <p14:sldId id="263"/>
             <p14:sldId id="264"/>
           </p14:sldIdLst>
         </p14:section>
-        <p14:section name="RAG" id="{ebf18e6f-2bb1-3bfa-a754-f7b81579c0c8}">
+        <p14:section name="RAG" id="{31dae672-6001-6fe2-dba4-025edbd77538}">
           <p14:sldIdLst>
             <p14:sldId id="265"/>
             <p14:sldId id="266"/>
           </p14:sldIdLst>
         </p14:section>
-        <p14:section name="Agent SDK and guardrails" id="{a469230e-6b23-3b59-9f77-3aee00413962}">
+        <p14:section name="Agent SDK and guardrails" id="{bd7e5325-818e-a160-6b68-06cdce4af1c8}">
           <p14:sldIdLst>
             <p14:sldId id="267"/>
             <p14:sldId id="268"/>
             <p14:sldId id="269"/>
           </p14:sldIdLst>
         </p14:section>
-        <p14:section name="The 70% rule" id="{1976abb9-6bc6-db72-76f8-ecfc275ca86f}">
+        <p14:section name="The 70% rule" id="{e6d2da03-53dd-a247-796d-462ed7d9bedb}">
           <p14:sldIdLst>
             <p14:sldId id="270"/>
             <p14:sldId id="271"/>
             <p14:sldId id="272"/>
           </p14:sldIdLst>
         </p14:section>
-        <p14:section name="Your task" id="{b4acfa28-fa56-a952-ed5a-76272e393ef4}">
+        <p14:section name="Your task" id="{82d28920-b9b4-9a05-d587-8aaccc7a8d65}">
           <p14:sldIdLst>
             <p14:sldId id="273"/>
             <p14:sldId id="274"/>
@@ -2958,11 +2958,11 @@
 
 <file path=ppt/slideLayouts/slideLayout2.xml><?xml version="1.0" encoding="utf-8"?>
 <p:sldLayout xmlns:a="http://schemas.openxmlformats.org/drawingml/2006/main" xmlns:r="http://schemas.openxmlformats.org/officeDocument/2006/relationships" xmlns:p="http://schemas.openxmlformats.org/presentationml/2006/main" preserve="1">
-  <p:cSld name="DARK_TITLE">
+  <p:cSld name="TITLE">
     <p:bg>
       <p:bgPr>
         <a:solidFill>
-          <a:schemeClr val="tx1"/>
+          <a:schemeClr val="bg1"/>
         </a:solidFill>
       </p:bgPr>
     </p:bg>
@@ -3006,7 +3006,7 @@
               <a:buNone/>
               <a:defRPr lang="en-US" sz="4600" b="1" dirty="0">
                 <a:solidFill>
-                  <a:schemeClr val="bg1"/>
+                  <a:schemeClr val="tx1"/>
                 </a:solidFill>
               </a:defRPr>
             </a:lvl1pPr>
@@ -3045,7 +3045,7 @@
               <a:buNone/>
               <a:defRPr lang="en-US" sz="2000" dirty="0">
                 <a:solidFill>
-                  <a:schemeClr val="accent6"/>
+                  <a:schemeClr val="accent4"/>
                 </a:solidFill>
               </a:defRPr>
             </a:lvl1pPr>
@@ -3068,11 +3068,11 @@
 
 <file path=ppt/slideLayouts/slideLayout3.xml><?xml version="1.0" encoding="utf-8"?>
 <p:sldLayout xmlns:a="http://schemas.openxmlformats.org/drawingml/2006/main" xmlns:r="http://schemas.openxmlformats.org/officeDocument/2006/relationships" xmlns:p="http://schemas.openxmlformats.org/presentationml/2006/main" preserve="1">
-  <p:cSld name="DARK_SECTION">
+  <p:cSld name="SECTION">
     <p:bg>
       <p:bgPr>
         <a:solidFill>
-          <a:schemeClr val="tx1"/>
+          <a:schemeClr val="bg1"/>
         </a:solidFill>
       </p:bgPr>
     </p:bg>
@@ -3116,7 +3116,7 @@
               <a:buNone/>
               <a:defRPr lang="en-US" sz="4000" b="1" dirty="0">
                 <a:solidFill>
-                  <a:schemeClr val="bg1"/>
+                  <a:schemeClr val="tx1"/>
                 </a:solidFill>
               </a:defRPr>
             </a:lvl1pPr>
@@ -3660,7 +3660,7 @@
             <a:r>
               <a:rPr lang="en-US" sz="4600" b="1" dirty="0">
                 <a:solidFill>
-                  <a:schemeClr val="bg1"/>
+                  <a:schemeClr val="tx1"/>
                 </a:solidFill>
               </a:rPr>
               <a:t>From Loop to Agent</a:t>
@@ -3698,7 +3698,7 @@
             <a:r>
               <a:rPr lang="en-US" sz="2000" dirty="0">
                 <a:solidFill>
-                  <a:schemeClr val="accent6"/>
+                  <a:schemeClr val="accent4"/>
                 </a:solidFill>
               </a:rPr>
               <a:t>Build, connect and guard a real AI agent</a:t>
@@ -3734,7 +3734,7 @@
             <a:r>
               <a:rPr lang="en-US" sz="1200" dirty="0">
                 <a:solidFill>
-                  <a:schemeClr val="accent5"/>
+                  <a:schemeClr val="accent4"/>
                 </a:solidFill>
               </a:rPr>
               <a:t>IIT Agentic AI Workshop  |  Day 1, Session 3  |  Jitesh Sureka</a:t>
@@ -3758,7 +3758,7 @@
             <a:avLst/>
           </a:prstGeom>
           <a:solidFill>
-            <a:schemeClr val="tx2"/>
+            <a:schemeClr val="accent1"/>
           </a:solidFill>
           <a:ln/>
         </p:spPr>
@@ -3869,7 +3869,12 @@
           <a:solidFill>
             <a:schemeClr val="bg2"/>
           </a:solidFill>
-          <a:ln/>
+          <a:ln w="9525">
+            <a:solidFill>
+              <a:srgbClr val="B8C0CC"/>
+            </a:solidFill>
+            <a:prstDash val="solid"/>
+          </a:ln>
         </p:spPr>
       </p:sp>
       <p:sp>
@@ -3887,7 +3892,7 @@
             <a:avLst/>
           </a:prstGeom>
           <a:solidFill>
-            <a:schemeClr val="tx1"/>
+            <a:schemeClr val="accent1"/>
           </a:solidFill>
           <a:ln/>
         </p:spPr>
@@ -4031,7 +4036,12 @@
           <a:solidFill>
             <a:schemeClr val="bg2"/>
           </a:solidFill>
-          <a:ln/>
+          <a:ln w="9525">
+            <a:solidFill>
+              <a:srgbClr val="B8C0CC"/>
+            </a:solidFill>
+            <a:prstDash val="solid"/>
+          </a:ln>
         </p:spPr>
       </p:sp>
       <p:sp>
@@ -4049,7 +4059,7 @@
             <a:avLst/>
           </a:prstGeom>
           <a:solidFill>
-            <a:schemeClr val="tx1"/>
+            <a:schemeClr val="accent1"/>
           </a:solidFill>
           <a:ln/>
         </p:spPr>
@@ -4193,7 +4203,12 @@
           <a:solidFill>
             <a:schemeClr val="bg2"/>
           </a:solidFill>
-          <a:ln/>
+          <a:ln w="9525">
+            <a:solidFill>
+              <a:srgbClr val="B8C0CC"/>
+            </a:solidFill>
+            <a:prstDash val="solid"/>
+          </a:ln>
         </p:spPr>
       </p:sp>
       <p:sp>
@@ -4211,7 +4226,7 @@
             <a:avLst/>
           </a:prstGeom>
           <a:solidFill>
-            <a:schemeClr val="tx1"/>
+            <a:schemeClr val="accent1"/>
           </a:solidFill>
           <a:ln/>
         </p:spPr>
@@ -4355,7 +4370,12 @@
           <a:solidFill>
             <a:schemeClr val="bg2"/>
           </a:solidFill>
-          <a:ln/>
+          <a:ln w="9525">
+            <a:solidFill>
+              <a:srgbClr val="B8C0CC"/>
+            </a:solidFill>
+            <a:prstDash val="solid"/>
+          </a:ln>
         </p:spPr>
       </p:sp>
       <p:sp>
@@ -4373,7 +4393,7 @@
             <a:avLst/>
           </a:prstGeom>
           <a:solidFill>
-            <a:schemeClr val="tx1"/>
+            <a:schemeClr val="accent1"/>
           </a:solidFill>
           <a:ln/>
         </p:spPr>
@@ -4517,7 +4537,12 @@
           <a:solidFill>
             <a:schemeClr val="bg2"/>
           </a:solidFill>
-          <a:ln/>
+          <a:ln w="9525">
+            <a:solidFill>
+              <a:srgbClr val="B8C0CC"/>
+            </a:solidFill>
+            <a:prstDash val="solid"/>
+          </a:ln>
         </p:spPr>
       </p:sp>
       <p:sp>
@@ -4535,7 +4560,7 @@
             <a:avLst/>
           </a:prstGeom>
           <a:solidFill>
-            <a:schemeClr val="tx1"/>
+            <a:schemeClr val="accent1"/>
           </a:solidFill>
           <a:ln/>
         </p:spPr>
@@ -4655,7 +4680,12 @@
           <a:solidFill>
             <a:schemeClr val="bg2"/>
           </a:solidFill>
-          <a:ln/>
+          <a:ln w="9525">
+            <a:solidFill>
+              <a:srgbClr val="B8C0CC"/>
+            </a:solidFill>
+            <a:prstDash val="solid"/>
+          </a:ln>
         </p:spPr>
       </p:sp>
       <p:sp>
@@ -4741,7 +4771,12 @@
           <a:solidFill>
             <a:schemeClr val="bg2"/>
           </a:solidFill>
-          <a:ln/>
+          <a:ln w="9525">
+            <a:solidFill>
+              <a:srgbClr val="B8C0CC"/>
+            </a:solidFill>
+            <a:prstDash val="solid"/>
+          </a:ln>
         </p:spPr>
       </p:sp>
       <p:sp>
@@ -4933,9 +4968,14 @@
             </a:avLst>
           </a:prstGeom>
           <a:solidFill>
-            <a:schemeClr val="tx1"/>
+            <a:schemeClr val="bg2"/>
           </a:solidFill>
-          <a:ln/>
+          <a:ln w="9525">
+            <a:solidFill>
+              <a:srgbClr val="B8C0CC"/>
+            </a:solidFill>
+            <a:prstDash val="solid"/>
+          </a:ln>
         </p:spPr>
       </p:sp>
       <p:sp>
@@ -4982,7 +5022,7 @@
             <a:r>
               <a:rPr lang="en-US" sz="1200" dirty="0">
                 <a:solidFill>
-                  <a:schemeClr val="bg1"/>
+                  <a:schemeClr val="tx1"/>
                 </a:solidFill>
                 <a:latin typeface="Courier New" pitchFamily="34" charset="0"/>
                 <a:ea typeface="Courier New" pitchFamily="34" charset="-122"/>
@@ -5016,7 +5056,7 @@
             <a:r>
               <a:rPr lang="en-US" sz="1200" dirty="0">
                 <a:solidFill>
-                  <a:schemeClr val="bg1"/>
+                  <a:schemeClr val="tx1"/>
                 </a:solidFill>
                 <a:latin typeface="Courier New" pitchFamily="34" charset="0"/>
                 <a:ea typeface="Courier New" pitchFamily="34" charset="-122"/>
@@ -5033,7 +5073,7 @@
             <a:r>
               <a:rPr lang="en-US" sz="1200" dirty="0">
                 <a:solidFill>
-                  <a:schemeClr val="bg1"/>
+                  <a:schemeClr val="tx1"/>
                 </a:solidFill>
                 <a:latin typeface="Courier New" pitchFamily="34" charset="0"/>
                 <a:ea typeface="Courier New" pitchFamily="34" charset="-122"/>
@@ -5056,7 +5096,7 @@
             <a:r>
               <a:rPr lang="en-US" sz="1200" dirty="0">
                 <a:solidFill>
-                  <a:schemeClr val="bg1"/>
+                  <a:schemeClr val="tx1"/>
                 </a:solidFill>
                 <a:latin typeface="Courier New" pitchFamily="34" charset="0"/>
                 <a:ea typeface="Courier New" pitchFamily="34" charset="-122"/>
@@ -5073,7 +5113,7 @@
             <a:r>
               <a:rPr lang="en-US" sz="1200" dirty="0">
                 <a:solidFill>
-                  <a:schemeClr val="bg1"/>
+                  <a:schemeClr val="tx1"/>
                 </a:solidFill>
                 <a:latin typeface="Courier New" pitchFamily="34" charset="0"/>
                 <a:ea typeface="Courier New" pitchFamily="34" charset="-122"/>
@@ -5090,7 +5130,7 @@
             <a:r>
               <a:rPr lang="en-US" sz="1200" dirty="0">
                 <a:solidFill>
-                  <a:schemeClr val="bg1"/>
+                  <a:schemeClr val="tx1"/>
                 </a:solidFill>
                 <a:latin typeface="Courier New" pitchFamily="34" charset="0"/>
                 <a:ea typeface="Courier New" pitchFamily="34" charset="-122"/>
@@ -5107,7 +5147,7 @@
             <a:r>
               <a:rPr lang="en-US" sz="1200" dirty="0">
                 <a:solidFill>
-                  <a:schemeClr val="bg1"/>
+                  <a:schemeClr val="tx1"/>
                 </a:solidFill>
                 <a:latin typeface="Courier New" pitchFamily="34" charset="0"/>
                 <a:ea typeface="Courier New" pitchFamily="34" charset="-122"/>
@@ -5124,7 +5164,7 @@
             <a:r>
               <a:rPr lang="en-US" sz="1200" dirty="0">
                 <a:solidFill>
-                  <a:schemeClr val="bg1"/>
+                  <a:schemeClr val="tx1"/>
                 </a:solidFill>
                 <a:latin typeface="Courier New" pitchFamily="34" charset="0"/>
                 <a:ea typeface="Courier New" pitchFamily="34" charset="-122"/>
@@ -5429,9 +5469,14 @@
             </a:avLst>
           </a:prstGeom>
           <a:solidFill>
-            <a:schemeClr val="tx1"/>
+            <a:schemeClr val="accent6"/>
           </a:solidFill>
-          <a:ln/>
+          <a:ln w="9525">
+            <a:solidFill>
+              <a:srgbClr val="B8C0CC"/>
+            </a:solidFill>
+            <a:prstDash val="solid"/>
+          </a:ln>
         </p:spPr>
       </p:sp>
       <p:sp>
@@ -5517,9 +5562,9 @@
               <a:buNone/>
             </a:pPr>
             <a:r>
-              <a:rPr lang="en-US" sz="1200" dirty="0">
-                <a:solidFill>
-                  <a:schemeClr val="bg1"/>
+              <a:rPr lang="en-US" sz="1200" b="1" dirty="0">
+                <a:solidFill>
+                  <a:schemeClr val="tx1"/>
                 </a:solidFill>
                 <a:latin typeface="Courier New" pitchFamily="34" charset="0"/>
                 <a:ea typeface="Courier New" pitchFamily="34" charset="-122"/>
@@ -5658,7 +5703,12 @@
           <a:solidFill>
             <a:schemeClr val="bg2"/>
           </a:solidFill>
-          <a:ln/>
+          <a:ln w="9525">
+            <a:solidFill>
+              <a:srgbClr val="B8C0CC"/>
+            </a:solidFill>
+            <a:prstDash val="solid"/>
+          </a:ln>
         </p:spPr>
       </p:sp>
       <p:sp>
@@ -5954,9 +6004,14 @@
             </a:avLst>
           </a:prstGeom>
           <a:solidFill>
-            <a:schemeClr val="tx1"/>
+            <a:schemeClr val="bg2"/>
           </a:solidFill>
-          <a:ln/>
+          <a:ln w="9525">
+            <a:solidFill>
+              <a:srgbClr val="B8C0CC"/>
+            </a:solidFill>
+            <a:prstDash val="solid"/>
+          </a:ln>
         </p:spPr>
       </p:sp>
       <p:sp>
@@ -5986,7 +6041,7 @@
             <a:r>
               <a:rPr lang="en-US" sz="1200" dirty="0">
                 <a:solidFill>
-                  <a:schemeClr val="bg1"/>
+                  <a:schemeClr val="tx1"/>
                 </a:solidFill>
                 <a:latin typeface="Courier New" pitchFamily="34" charset="0"/>
                 <a:ea typeface="Courier New" pitchFamily="34" charset="-122"/>
@@ -6003,7 +6058,7 @@
             <a:r>
               <a:rPr lang="en-US" sz="1200" dirty="0">
                 <a:solidFill>
-                  <a:schemeClr val="bg1"/>
+                  <a:schemeClr val="tx1"/>
                 </a:solidFill>
                 <a:latin typeface="Courier New" pitchFamily="34" charset="0"/>
                 <a:ea typeface="Courier New" pitchFamily="34" charset="-122"/>
@@ -6020,7 +6075,7 @@
             <a:r>
               <a:rPr lang="en-US" sz="1200" dirty="0">
                 <a:solidFill>
-                  <a:schemeClr val="bg1"/>
+                  <a:schemeClr val="tx1"/>
                 </a:solidFill>
                 <a:latin typeface="Courier New" pitchFamily="34" charset="0"/>
                 <a:ea typeface="Courier New" pitchFamily="34" charset="-122"/>
@@ -6037,7 +6092,7 @@
             <a:r>
               <a:rPr lang="en-US" sz="1200" dirty="0">
                 <a:solidFill>
-                  <a:schemeClr val="bg1"/>
+                  <a:schemeClr val="tx1"/>
                 </a:solidFill>
                 <a:latin typeface="Courier New" pitchFamily="34" charset="0"/>
                 <a:ea typeface="Courier New" pitchFamily="34" charset="-122"/>
@@ -6054,7 +6109,7 @@
             <a:r>
               <a:rPr lang="en-US" sz="1200" dirty="0">
                 <a:solidFill>
-                  <a:schemeClr val="bg1"/>
+                  <a:schemeClr val="tx1"/>
                 </a:solidFill>
                 <a:latin typeface="Courier New" pitchFamily="34" charset="0"/>
                 <a:ea typeface="Courier New" pitchFamily="34" charset="-122"/>
@@ -6071,7 +6126,7 @@
             <a:r>
               <a:rPr lang="en-US" sz="1200" dirty="0">
                 <a:solidFill>
-                  <a:schemeClr val="bg1"/>
+                  <a:schemeClr val="tx1"/>
                 </a:solidFill>
                 <a:latin typeface="Courier New" pitchFamily="34" charset="0"/>
                 <a:ea typeface="Courier New" pitchFamily="34" charset="-122"/>
@@ -6088,7 +6143,7 @@
             <a:r>
               <a:rPr lang="en-US" sz="1200" dirty="0">
                 <a:solidFill>
-                  <a:schemeClr val="bg1"/>
+                  <a:schemeClr val="tx1"/>
                 </a:solidFill>
                 <a:latin typeface="Courier New" pitchFamily="34" charset="0"/>
                 <a:ea typeface="Courier New" pitchFamily="34" charset="-122"/>
@@ -6105,7 +6160,7 @@
             <a:r>
               <a:rPr lang="en-US" sz="1200" dirty="0">
                 <a:solidFill>
-                  <a:schemeClr val="bg1"/>
+                  <a:schemeClr val="tx1"/>
                 </a:solidFill>
                 <a:latin typeface="Courier New" pitchFamily="34" charset="0"/>
                 <a:ea typeface="Courier New" pitchFamily="34" charset="-122"/>
@@ -6122,7 +6177,7 @@
             <a:r>
               <a:rPr lang="en-US" sz="1200" dirty="0">
                 <a:solidFill>
-                  <a:schemeClr val="bg1"/>
+                  <a:schemeClr val="tx1"/>
                 </a:solidFill>
                 <a:latin typeface="Courier New" pitchFamily="34" charset="0"/>
                 <a:ea typeface="Courier New" pitchFamily="34" charset="-122"/>
@@ -6297,7 +6352,12 @@
           <a:solidFill>
             <a:schemeClr val="bg2"/>
           </a:solidFill>
-          <a:ln/>
+          <a:ln w="9525">
+            <a:solidFill>
+              <a:srgbClr val="B8C0CC"/>
+            </a:solidFill>
+            <a:prstDash val="solid"/>
+          </a:ln>
         </p:spPr>
       </p:sp>
       <p:sp>
@@ -6315,7 +6375,7 @@
             <a:avLst/>
           </a:prstGeom>
           <a:solidFill>
-            <a:schemeClr val="tx1"/>
+            <a:schemeClr val="accent1"/>
           </a:solidFill>
           <a:ln/>
         </p:spPr>
@@ -6510,7 +6570,12 @@
           <a:solidFill>
             <a:schemeClr val="bg2"/>
           </a:solidFill>
-          <a:ln/>
+          <a:ln w="9525">
+            <a:solidFill>
+              <a:srgbClr val="B8C0CC"/>
+            </a:solidFill>
+            <a:prstDash val="solid"/>
+          </a:ln>
         </p:spPr>
       </p:sp>
       <p:sp>
@@ -6528,7 +6593,7 @@
             <a:avLst/>
           </a:prstGeom>
           <a:solidFill>
-            <a:schemeClr val="tx1"/>
+            <a:schemeClr val="accent1"/>
           </a:solidFill>
           <a:ln/>
         </p:spPr>
@@ -6723,7 +6788,12 @@
           <a:solidFill>
             <a:schemeClr val="bg2"/>
           </a:solidFill>
-          <a:ln/>
+          <a:ln w="9525">
+            <a:solidFill>
+              <a:srgbClr val="B8C0CC"/>
+            </a:solidFill>
+            <a:prstDash val="solid"/>
+          </a:ln>
         </p:spPr>
       </p:sp>
       <p:sp>
@@ -6741,7 +6811,7 @@
             <a:avLst/>
           </a:prstGeom>
           <a:solidFill>
-            <a:schemeClr val="tx1"/>
+            <a:schemeClr val="accent1"/>
           </a:solidFill>
           <a:ln/>
         </p:spPr>
@@ -6936,7 +7006,12 @@
           <a:solidFill>
             <a:schemeClr val="bg2"/>
           </a:solidFill>
-          <a:ln/>
+          <a:ln w="9525">
+            <a:solidFill>
+              <a:srgbClr val="B8C0CC"/>
+            </a:solidFill>
+            <a:prstDash val="solid"/>
+          </a:ln>
         </p:spPr>
       </p:sp>
       <p:sp>
@@ -6954,7 +7029,7 @@
             <a:avLst/>
           </a:prstGeom>
           <a:solidFill>
-            <a:schemeClr val="tx1"/>
+            <a:schemeClr val="accent1"/>
           </a:solidFill>
           <a:ln/>
         </p:spPr>
@@ -7291,9 +7366,14 @@
             </a:avLst>
           </a:prstGeom>
           <a:solidFill>
-            <a:schemeClr val="tx1"/>
+            <a:schemeClr val="bg2"/>
           </a:solidFill>
-          <a:ln/>
+          <a:ln w="9525">
+            <a:solidFill>
+              <a:srgbClr val="B8C0CC"/>
+            </a:solidFill>
+            <a:prstDash val="solid"/>
+          </a:ln>
         </p:spPr>
       </p:sp>
       <p:sp>
@@ -7323,7 +7403,7 @@
             <a:r>
               <a:rPr lang="en-US" sz="1200" dirty="0">
                 <a:solidFill>
-                  <a:schemeClr val="bg1"/>
+                  <a:schemeClr val="tx1"/>
                 </a:solidFill>
                 <a:latin typeface="Courier New" pitchFamily="34" charset="0"/>
                 <a:ea typeface="Courier New" pitchFamily="34" charset="-122"/>
@@ -7340,7 +7420,7 @@
             <a:r>
               <a:rPr lang="en-US" sz="1200" dirty="0">
                 <a:solidFill>
-                  <a:schemeClr val="bg1"/>
+                  <a:schemeClr val="tx1"/>
                 </a:solidFill>
                 <a:latin typeface="Courier New" pitchFamily="34" charset="0"/>
                 <a:ea typeface="Courier New" pitchFamily="34" charset="-122"/>
@@ -7357,7 +7437,7 @@
             <a:r>
               <a:rPr lang="en-US" sz="1200" dirty="0">
                 <a:solidFill>
-                  <a:schemeClr val="bg1"/>
+                  <a:schemeClr val="tx1"/>
                 </a:solidFill>
                 <a:latin typeface="Courier New" pitchFamily="34" charset="0"/>
                 <a:ea typeface="Courier New" pitchFamily="34" charset="-122"/>
@@ -7374,7 +7454,7 @@
             <a:r>
               <a:rPr lang="en-US" sz="1200" dirty="0">
                 <a:solidFill>
-                  <a:schemeClr val="bg1"/>
+                  <a:schemeClr val="tx1"/>
                 </a:solidFill>
                 <a:latin typeface="Courier New" pitchFamily="34" charset="0"/>
                 <a:ea typeface="Courier New" pitchFamily="34" charset="-122"/>
@@ -7391,7 +7471,7 @@
             <a:r>
               <a:rPr lang="en-US" sz="1200" dirty="0">
                 <a:solidFill>
-                  <a:schemeClr val="bg1"/>
+                  <a:schemeClr val="tx1"/>
                 </a:solidFill>
                 <a:latin typeface="Courier New" pitchFamily="34" charset="0"/>
                 <a:ea typeface="Courier New" pitchFamily="34" charset="-122"/>
@@ -7408,7 +7488,7 @@
             <a:r>
               <a:rPr lang="en-US" sz="1200" dirty="0">
                 <a:solidFill>
-                  <a:schemeClr val="bg1"/>
+                  <a:schemeClr val="tx1"/>
                 </a:solidFill>
                 <a:latin typeface="Courier New" pitchFamily="34" charset="0"/>
                 <a:ea typeface="Courier New" pitchFamily="34" charset="-122"/>
@@ -7425,7 +7505,7 @@
             <a:r>
               <a:rPr lang="en-US" sz="1200" dirty="0">
                 <a:solidFill>
-                  <a:schemeClr val="bg1"/>
+                  <a:schemeClr val="tx1"/>
                 </a:solidFill>
                 <a:latin typeface="Courier New" pitchFamily="34" charset="0"/>
                 <a:ea typeface="Courier New" pitchFamily="34" charset="-122"/>
@@ -7442,7 +7522,7 @@
             <a:r>
               <a:rPr lang="en-US" sz="1200" dirty="0">
                 <a:solidFill>
-                  <a:schemeClr val="bg1"/>
+                  <a:schemeClr val="tx1"/>
                 </a:solidFill>
                 <a:latin typeface="Courier New" pitchFamily="34" charset="0"/>
                 <a:ea typeface="Courier New" pitchFamily="34" charset="-122"/>
@@ -7783,9 +7863,14 @@
             </a:avLst>
           </a:prstGeom>
           <a:solidFill>
-            <a:schemeClr val="tx1"/>
+            <a:schemeClr val="accent6"/>
           </a:solidFill>
-          <a:ln/>
+          <a:ln w="9525">
+            <a:solidFill>
+              <a:srgbClr val="B8C0CC"/>
+            </a:solidFill>
+            <a:prstDash val="solid"/>
+          </a:ln>
         </p:spPr>
       </p:sp>
       <p:sp>
@@ -7871,9 +7956,9 @@
               <a:buNone/>
             </a:pPr>
             <a:r>
-              <a:rPr lang="en-US" sz="1200" dirty="0">
-                <a:solidFill>
-                  <a:schemeClr val="bg1"/>
+              <a:rPr lang="en-US" sz="1200" b="1" dirty="0">
+                <a:solidFill>
+                  <a:schemeClr val="tx1"/>
                 </a:solidFill>
                 <a:latin typeface="Courier New" pitchFamily="34" charset="0"/>
                 <a:ea typeface="Courier New" pitchFamily="34" charset="-122"/>
@@ -8068,9 +8153,14 @@
             </a:avLst>
           </a:prstGeom>
           <a:solidFill>
-            <a:schemeClr val="tx1"/>
+            <a:schemeClr val="accent5"/>
           </a:solidFill>
-          <a:ln/>
+          <a:ln w="19050">
+            <a:solidFill>
+              <a:srgbClr val="0B6E66"/>
+            </a:solidFill>
+            <a:prstDash val="solid"/>
+          </a:ln>
         </p:spPr>
       </p:sp>
       <p:sp>
@@ -8100,7 +8190,7 @@
             <a:r>
               <a:rPr lang="en-US" sz="2200" b="1" dirty="0">
                 <a:solidFill>
-                  <a:schemeClr val="bg1"/>
+                  <a:schemeClr val="tx1"/>
                 </a:solidFill>
               </a:rPr>
               <a:t>30%  you</a:t>
@@ -8128,7 +8218,12 @@
           <a:solidFill>
             <a:schemeClr val="bg2"/>
           </a:solidFill>
-          <a:ln/>
+          <a:ln w="9525">
+            <a:solidFill>
+              <a:srgbClr val="B8C0CC"/>
+            </a:solidFill>
+            <a:prstDash val="solid"/>
+          </a:ln>
         </p:spPr>
       </p:sp>
       <p:sp>
@@ -8261,7 +8356,12 @@
           <a:solidFill>
             <a:schemeClr val="bg2"/>
           </a:solidFill>
-          <a:ln/>
+          <a:ln w="9525">
+            <a:solidFill>
+              <a:srgbClr val="B8C0CC"/>
+            </a:solidFill>
+            <a:prstDash val="solid"/>
+          </a:ln>
         </p:spPr>
       </p:sp>
       <p:sp>
@@ -8502,7 +8602,12 @@
           <a:solidFill>
             <a:schemeClr val="bg2"/>
           </a:solidFill>
-          <a:ln/>
+          <a:ln w="9525">
+            <a:solidFill>
+              <a:srgbClr val="B8C0CC"/>
+            </a:solidFill>
+            <a:prstDash val="solid"/>
+          </a:ln>
         </p:spPr>
       </p:sp>
       <p:sp>
@@ -8520,7 +8625,7 @@
             <a:avLst/>
           </a:prstGeom>
           <a:solidFill>
-            <a:schemeClr val="tx1"/>
+            <a:schemeClr val="accent1"/>
           </a:solidFill>
           <a:ln/>
         </p:spPr>
@@ -8640,7 +8745,12 @@
           <a:solidFill>
             <a:schemeClr val="bg2"/>
           </a:solidFill>
-          <a:ln/>
+          <a:ln w="9525">
+            <a:solidFill>
+              <a:srgbClr val="B8C0CC"/>
+            </a:solidFill>
+            <a:prstDash val="solid"/>
+          </a:ln>
         </p:spPr>
       </p:sp>
       <p:sp>
@@ -8658,7 +8768,7 @@
             <a:avLst/>
           </a:prstGeom>
           <a:solidFill>
-            <a:schemeClr val="tx1"/>
+            <a:schemeClr val="accent1"/>
           </a:solidFill>
           <a:ln/>
         </p:spPr>
@@ -8778,7 +8888,12 @@
           <a:solidFill>
             <a:schemeClr val="bg2"/>
           </a:solidFill>
-          <a:ln/>
+          <a:ln w="9525">
+            <a:solidFill>
+              <a:srgbClr val="B8C0CC"/>
+            </a:solidFill>
+            <a:prstDash val="solid"/>
+          </a:ln>
         </p:spPr>
       </p:sp>
       <p:sp>
@@ -8796,7 +8911,7 @@
             <a:avLst/>
           </a:prstGeom>
           <a:solidFill>
-            <a:schemeClr val="tx1"/>
+            <a:schemeClr val="accent1"/>
           </a:solidFill>
           <a:ln/>
         </p:spPr>
@@ -9032,7 +9147,7 @@
             <a:r>
               <a:rPr lang="en-US" sz="4000" b="1" dirty="0">
                 <a:solidFill>
-                  <a:schemeClr val="bg1"/>
+                  <a:schemeClr val="tx1"/>
                 </a:solidFill>
               </a:rPr>
               <a:t>Six upgrades, one agent</a:t>
@@ -9124,7 +9239,7 @@
             <a:r>
               <a:rPr lang="en-US" sz="1600" dirty="0">
                 <a:solidFill>
-                  <a:schemeClr val="bg1"/>
+                  <a:schemeClr val="tx1"/>
                 </a:solidFill>
               </a:rPr>
               <a:t>A loop that calls tools, with a step cap</a:t>
@@ -9216,7 +9331,7 @@
             <a:r>
               <a:rPr lang="en-US" sz="1600" dirty="0">
                 <a:solidFill>
-                  <a:schemeClr val="bg1"/>
+                  <a:schemeClr val="tx1"/>
                 </a:solidFill>
               </a:rPr>
               <a:t>Patterns: ReAct, plan first, reflection</a:t>
@@ -9308,7 +9423,7 @@
             <a:r>
               <a:rPr lang="en-US" sz="1600" dirty="0">
                 <a:solidFill>
-                  <a:schemeClr val="bg1"/>
+                  <a:schemeClr val="tx1"/>
                 </a:solidFill>
               </a:rPr>
               <a:t>MCP: one plug, tools reused everywhere</a:t>
@@ -9400,7 +9515,7 @@
             <a:r>
               <a:rPr lang="en-US" sz="1600" dirty="0">
                 <a:solidFill>
-                  <a:schemeClr val="bg1"/>
+                  <a:schemeClr val="tx1"/>
                 </a:solidFill>
               </a:rPr>
               <a:t>RAG: cited answers, or "not in the notes"</a:t>
@@ -9492,7 +9607,7 @@
             <a:r>
               <a:rPr lang="en-US" sz="1600" dirty="0">
                 <a:solidFill>
-                  <a:schemeClr val="bg1"/>
+                  <a:schemeClr val="tx1"/>
                 </a:solidFill>
               </a:rPr>
               <a:t>Agent SDK: the loop is no longer yours</a:t>
@@ -9584,7 +9699,7 @@
             <a:r>
               <a:rPr lang="en-US" sz="1600" dirty="0">
                 <a:solidFill>
-                  <a:schemeClr val="bg1"/>
+                  <a:schemeClr val="tx1"/>
                 </a:solidFill>
               </a:rPr>
               <a:t>Guardrails in code, and a human on every write</a:t>
@@ -9647,7 +9762,7 @@
             <a:r>
               <a:rPr lang="en-US" sz="4000" b="1" dirty="0">
                 <a:solidFill>
-                  <a:schemeClr val="bg1"/>
+                  <a:schemeClr val="tx1"/>
                 </a:solidFill>
               </a:rPr>
               <a:t>Your turn: build it</a:t>
@@ -9665,7 +9780,7 @@
         <p:spPr>
           <a:xfrm>
             <a:off x="640080" y="1737360"/>
-            <a:ext cx="7680960" cy="640080"/>
+            <a:ext cx="5669280" cy="640080"/>
           </a:xfrm>
           <a:prstGeom prst="rect">
             <a:avLst/>
@@ -9681,9 +9796,9 @@
               <a:buNone/>
             </a:pPr>
             <a:r>
-              <a:rPr lang="en-US" sz="2000" dirty="0">
-                <a:solidFill>
-                  <a:schemeClr val="accent6"/>
+              <a:rPr lang="en-US" sz="2000" b="1" dirty="0">
+                <a:solidFill>
+                  <a:schemeClr val="tx1"/>
                 </a:solidFill>
               </a:rPr>
               <a:t>7 steps. Each has a "Done when" check. Do not move on until it passes.</a:t>
@@ -9701,7 +9816,7 @@
         <p:spPr>
           <a:xfrm>
             <a:off x="640080" y="2743200"/>
-            <a:ext cx="7680960" cy="822960"/>
+            <a:ext cx="5669280" cy="822960"/>
           </a:xfrm>
           <a:prstGeom prst="rect">
             <a:avLst/>
@@ -9719,7 +9834,7 @@
             <a:r>
               <a:rPr lang="en-US" sz="1600" dirty="0">
                 <a:solidFill>
-                  <a:schemeClr val="accent5"/>
+                  <a:schemeClr val="accent4"/>
                 </a:solidFill>
               </a:rPr>
               <a:t>Short on time? Skip Step 4 and Step 6 first.</a:t>
@@ -9733,7 +9848,7 @@
             <a:r>
               <a:rPr lang="en-US" sz="1600" dirty="0">
                 <a:solidFill>
-                  <a:schemeClr val="accent5"/>
+                  <a:schemeClr val="accent4"/>
                 </a:solidFill>
               </a:rPr>
               <a:t>Full handout: handout/student-task.md</a:t>
@@ -9742,6 +9857,50 @@
           </a:p>
         </p:txBody>
       </p:sp>
+      <p:sp>
+        <p:nvSpPr>
+          <p:cNvPr id="5" name="divider circle"/>
+          <p:cNvSpPr/>
+          <p:nvPr/>
+        </p:nvSpPr>
+        <p:spPr>
+          <a:xfrm>
+            <a:off x="6766560" y="1737360"/>
+            <a:ext cx="1737360" cy="1737360"/>
+          </a:xfrm>
+          <a:prstGeom prst="ellipse">
+            <a:avLst/>
+          </a:prstGeom>
+          <a:solidFill>
+            <a:schemeClr val="accent1"/>
+          </a:solidFill>
+          <a:ln/>
+        </p:spPr>
+      </p:sp>
+      <p:pic>
+        <p:nvPicPr>
+          <p:cNvPr id="6" name="divider icon" descr="preencoded.png">    </p:cNvPr>
+          <p:cNvPicPr>
+            <a:picLocks noChangeAspect="1"/>
+          </p:cNvPicPr>
+          <p:nvPr/>
+        </p:nvPicPr>
+        <p:blipFill>
+          <a:blip r:embed="rId1"/>
+          <a:stretch>
+            <a:fillRect/>
+          </a:stretch>
+        </p:blipFill>
+        <p:spPr>
+          <a:xfrm>
+            <a:off x="7223760" y="2194560"/>
+            <a:ext cx="822960" cy="822960"/>
+          </a:xfrm>
+          <a:prstGeom prst="rect">
+            <a:avLst/>
+          </a:prstGeom>
+        </p:spPr>
+      </p:pic>
     </p:spTree>
   </p:cSld>
   <p:clrMapOvr>
@@ -9822,9 +9981,14 @@
             </a:avLst>
           </a:prstGeom>
           <a:solidFill>
-            <a:schemeClr val="tx1"/>
+            <a:schemeClr val="bg2"/>
           </a:solidFill>
-          <a:ln/>
+          <a:ln w="9525">
+            <a:solidFill>
+              <a:srgbClr val="B8C0CC"/>
+            </a:solidFill>
+            <a:prstDash val="solid"/>
+          </a:ln>
         </p:spPr>
       </p:sp>
       <p:sp>
@@ -9854,7 +10018,7 @@
             <a:r>
               <a:rPr lang="en-US" sz="1200" dirty="0">
                 <a:solidFill>
-                  <a:schemeClr val="bg1"/>
+                  <a:schemeClr val="tx1"/>
                 </a:solidFill>
                 <a:latin typeface="Courier New" pitchFamily="34" charset="0"/>
                 <a:ea typeface="Courier New" pitchFamily="34" charset="-122"/>
@@ -9871,7 +10035,7 @@
             <a:r>
               <a:rPr lang="en-US" sz="1200" dirty="0">
                 <a:solidFill>
-                  <a:schemeClr val="bg1"/>
+                  <a:schemeClr val="tx1"/>
                 </a:solidFill>
                 <a:latin typeface="Courier New" pitchFamily="34" charset="0"/>
                 <a:ea typeface="Courier New" pitchFamily="34" charset="-122"/>
@@ -9888,7 +10052,7 @@
             <a:r>
               <a:rPr lang="en-US" sz="1200" dirty="0">
                 <a:solidFill>
-                  <a:schemeClr val="bg1"/>
+                  <a:schemeClr val="tx1"/>
                 </a:solidFill>
                 <a:latin typeface="Courier New" pitchFamily="34" charset="0"/>
                 <a:ea typeface="Courier New" pitchFamily="34" charset="-122"/>
@@ -9905,7 +10069,7 @@
             <a:r>
               <a:rPr lang="en-US" sz="1200" dirty="0">
                 <a:solidFill>
-                  <a:schemeClr val="bg1"/>
+                  <a:schemeClr val="tx1"/>
                 </a:solidFill>
                 <a:latin typeface="Courier New" pitchFamily="34" charset="0"/>
                 <a:ea typeface="Courier New" pitchFamily="34" charset="-122"/>
@@ -9922,7 +10086,7 @@
             <a:r>
               <a:rPr lang="en-US" sz="1200" dirty="0">
                 <a:solidFill>
-                  <a:schemeClr val="bg1"/>
+                  <a:schemeClr val="tx1"/>
                 </a:solidFill>
                 <a:latin typeface="Courier New" pitchFamily="34" charset="0"/>
                 <a:ea typeface="Courier New" pitchFamily="34" charset="-122"/>
@@ -9939,7 +10103,7 @@
             <a:r>
               <a:rPr lang="en-US" sz="1200" dirty="0">
                 <a:solidFill>
-                  <a:schemeClr val="bg1"/>
+                  <a:schemeClr val="tx1"/>
                 </a:solidFill>
                 <a:latin typeface="Courier New" pitchFamily="34" charset="0"/>
                 <a:ea typeface="Courier New" pitchFamily="34" charset="-122"/>
@@ -9956,7 +10120,7 @@
             <a:r>
               <a:rPr lang="en-US" sz="1200" dirty="0">
                 <a:solidFill>
-                  <a:schemeClr val="bg1"/>
+                  <a:schemeClr val="tx1"/>
                 </a:solidFill>
                 <a:latin typeface="Courier New" pitchFamily="34" charset="0"/>
                 <a:ea typeface="Courier New" pitchFamily="34" charset="-122"/>
@@ -10421,7 +10585,12 @@
           <a:solidFill>
             <a:schemeClr val="bg2"/>
           </a:solidFill>
-          <a:ln/>
+          <a:ln w="9525">
+            <a:solidFill>
+              <a:srgbClr val="B8C0CC"/>
+            </a:solidFill>
+            <a:prstDash val="solid"/>
+          </a:ln>
         </p:spPr>
       </p:sp>
       <p:sp>
@@ -10439,7 +10608,7 @@
             <a:avLst/>
           </a:prstGeom>
           <a:solidFill>
-            <a:schemeClr val="tx1"/>
+            <a:schemeClr val="accent1"/>
           </a:solidFill>
           <a:ln/>
         </p:spPr>
@@ -10559,7 +10728,12 @@
           <a:solidFill>
             <a:schemeClr val="bg2"/>
           </a:solidFill>
-          <a:ln/>
+          <a:ln w="9525">
+            <a:solidFill>
+              <a:srgbClr val="B8C0CC"/>
+            </a:solidFill>
+            <a:prstDash val="solid"/>
+          </a:ln>
         </p:spPr>
       </p:sp>
       <p:sp>
@@ -10577,7 +10751,7 @@
             <a:avLst/>
           </a:prstGeom>
           <a:solidFill>
-            <a:schemeClr val="tx1"/>
+            <a:schemeClr val="accent1"/>
           </a:solidFill>
           <a:ln/>
         </p:spPr>
@@ -10697,7 +10871,12 @@
           <a:solidFill>
             <a:schemeClr val="bg2"/>
           </a:solidFill>
-          <a:ln/>
+          <a:ln w="9525">
+            <a:solidFill>
+              <a:srgbClr val="B8C0CC"/>
+            </a:solidFill>
+            <a:prstDash val="solid"/>
+          </a:ln>
         </p:spPr>
       </p:sp>
       <p:sp>
@@ -10715,7 +10894,7 @@
             <a:avLst/>
           </a:prstGeom>
           <a:solidFill>
-            <a:schemeClr val="tx1"/>
+            <a:schemeClr val="accent1"/>
           </a:solidFill>
           <a:ln/>
         </p:spPr>
@@ -10835,7 +11014,12 @@
           <a:solidFill>
             <a:schemeClr val="bg2"/>
           </a:solidFill>
-          <a:ln/>
+          <a:ln w="9525">
+            <a:solidFill>
+              <a:srgbClr val="B8C0CC"/>
+            </a:solidFill>
+            <a:prstDash val="solid"/>
+          </a:ln>
         </p:spPr>
       </p:sp>
       <p:sp>
@@ -10853,7 +11037,7 @@
             <a:avLst/>
           </a:prstGeom>
           <a:solidFill>
-            <a:schemeClr val="tx1"/>
+            <a:schemeClr val="accent1"/>
           </a:solidFill>
           <a:ln/>
         </p:spPr>
@@ -10973,7 +11157,12 @@
           <a:solidFill>
             <a:schemeClr val="bg2"/>
           </a:solidFill>
-          <a:ln/>
+          <a:ln w="9525">
+            <a:solidFill>
+              <a:srgbClr val="B8C0CC"/>
+            </a:solidFill>
+            <a:prstDash val="solid"/>
+          </a:ln>
         </p:spPr>
       </p:sp>
       <p:sp>
@@ -10991,7 +11180,7 @@
             <a:avLst/>
           </a:prstGeom>
           <a:solidFill>
-            <a:schemeClr val="tx1"/>
+            <a:schemeClr val="accent1"/>
           </a:solidFill>
           <a:ln/>
         </p:spPr>
@@ -11125,7 +11314,12 @@
           <a:solidFill>
             <a:schemeClr val="bg2"/>
           </a:solidFill>
-          <a:ln/>
+          <a:ln w="9525">
+            <a:solidFill>
+              <a:srgbClr val="B8C0CC"/>
+            </a:solidFill>
+            <a:prstDash val="solid"/>
+          </a:ln>
         </p:spPr>
       </p:sp>
       <p:sp>
@@ -11143,7 +11337,7 @@
             <a:avLst/>
           </a:prstGeom>
           <a:solidFill>
-            <a:schemeClr val="tx1"/>
+            <a:schemeClr val="accent1"/>
           </a:solidFill>
           <a:ln/>
         </p:spPr>
@@ -11407,7 +11601,12 @@
           <a:solidFill>
             <a:schemeClr val="bg2"/>
           </a:solidFill>
-          <a:ln/>
+          <a:ln w="9525">
+            <a:solidFill>
+              <a:srgbClr val="B8C0CC"/>
+            </a:solidFill>
+            <a:prstDash val="solid"/>
+          </a:ln>
         </p:spPr>
       </p:sp>
       <p:sp>
@@ -11923,9 +12122,14 @@
             </a:avLst>
           </a:prstGeom>
           <a:solidFill>
-            <a:schemeClr val="tx1"/>
+            <a:schemeClr val="accent5"/>
           </a:solidFill>
-          <a:ln/>
+          <a:ln w="9525">
+            <a:solidFill>
+              <a:srgbClr val="B8C0CC"/>
+            </a:solidFill>
+            <a:prstDash val="solid"/>
+          </a:ln>
         </p:spPr>
       </p:sp>
       <p:pic>
@@ -12018,7 +12222,7 @@
             <a:r>
               <a:rPr lang="en-US" sz="1200" dirty="0">
                 <a:solidFill>
-                  <a:schemeClr val="bg1"/>
+                  <a:schemeClr val="tx1"/>
                 </a:solidFill>
                 <a:latin typeface="Courier New" pitchFamily="34" charset="0"/>
                 <a:ea typeface="Courier New" pitchFamily="34" charset="-122"/>
@@ -12038,7 +12242,7 @@
             <a:r>
               <a:rPr lang="en-US" sz="1400" dirty="0">
                 <a:solidFill>
-                  <a:schemeClr val="bg1"/>
+                  <a:schemeClr val="tx1"/>
                 </a:solidFill>
               </a:rPr>
               <a:t>makes 1 to 2 tool calls and names both calculators: the found one in Lab 3, and the lost one reported from Exam hall B.</a:t>
@@ -12174,7 +12378,12 @@
           <a:solidFill>
             <a:schemeClr val="bg2"/>
           </a:solidFill>
-          <a:ln/>
+          <a:ln w="9525">
+            <a:solidFill>
+              <a:srgbClr val="B8C0CC"/>
+            </a:solidFill>
+            <a:prstDash val="solid"/>
+          </a:ln>
         </p:spPr>
       </p:sp>
       <p:sp>
@@ -12690,9 +12899,14 @@
             </a:avLst>
           </a:prstGeom>
           <a:solidFill>
-            <a:schemeClr val="tx1"/>
+            <a:schemeClr val="accent5"/>
           </a:solidFill>
-          <a:ln/>
+          <a:ln w="9525">
+            <a:solidFill>
+              <a:srgbClr val="B8C0CC"/>
+            </a:solidFill>
+            <a:prstDash val="solid"/>
+          </a:ln>
         </p:spPr>
       </p:sp>
       <p:pic>
@@ -12785,7 +12999,7 @@
             <a:r>
               <a:rPr lang="en-US" sz="1400" dirty="0">
                 <a:solidFill>
-                  <a:schemeClr val="bg1"/>
+                  <a:schemeClr val="tx1"/>
                 </a:solidFill>
               </a:rPr>
               <a:t>You have a 3x3 table of results and one sentence:</a:t>
@@ -12802,7 +13016,7 @@
             <a:r>
               <a:rPr lang="en-US" sz="1400" b="1" dirty="0">
                 <a:solidFill>
-                  <a:schemeClr val="bg1"/>
+                  <a:schemeClr val="tx1"/>
                 </a:solidFill>
               </a:rPr>
               <a:t>"Use ___ when ___."</a:t>
@@ -12938,7 +13152,12 @@
           <a:solidFill>
             <a:schemeClr val="bg2"/>
           </a:solidFill>
-          <a:ln/>
+          <a:ln w="9525">
+            <a:solidFill>
+              <a:srgbClr val="B8C0CC"/>
+            </a:solidFill>
+            <a:prstDash val="solid"/>
+          </a:ln>
         </p:spPr>
       </p:sp>
       <p:sp>
@@ -13362,9 +13581,14 @@
             </a:avLst>
           </a:prstGeom>
           <a:solidFill>
-            <a:schemeClr val="tx1"/>
+            <a:schemeClr val="accent5"/>
           </a:solidFill>
-          <a:ln/>
+          <a:ln w="9525">
+            <a:solidFill>
+              <a:srgbClr val="B8C0CC"/>
+            </a:solidFill>
+            <a:prstDash val="solid"/>
+          </a:ln>
         </p:spPr>
       </p:sp>
       <p:pic>
@@ -13457,7 +13681,7 @@
             <a:r>
               <a:rPr lang="en-US" sz="1400" dirty="0">
                 <a:solidFill>
-                  <a:schemeClr val="bg1"/>
+                  <a:schemeClr val="tx1"/>
                 </a:solidFill>
               </a:rPr>
               <a:t>Claude Code shows a call to</a:t>
@@ -13474,7 +13698,7 @@
             <a:r>
               <a:rPr lang="en-US" sz="1200" dirty="0">
                 <a:solidFill>
-                  <a:schemeClr val="bg1"/>
+                  <a:schemeClr val="tx1"/>
                 </a:solidFill>
                 <a:latin typeface="Courier New" pitchFamily="34" charset="0"/>
                 <a:ea typeface="Courier New" pitchFamily="34" charset="-122"/>
@@ -13494,7 +13718,7 @@
             <a:r>
               <a:rPr lang="en-US" sz="1400" dirty="0">
                 <a:solidFill>
-                  <a:schemeClr val="bg1"/>
+                  <a:schemeClr val="tx1"/>
                 </a:solidFill>
               </a:rPr>
               <a:t>and answers from your data.</a:t>
@@ -13630,7 +13854,12 @@
           <a:solidFill>
             <a:schemeClr val="bg2"/>
           </a:solidFill>
-          <a:ln/>
+          <a:ln w="9525">
+            <a:solidFill>
+              <a:srgbClr val="B8C0CC"/>
+            </a:solidFill>
+            <a:prstDash val="solid"/>
+          </a:ln>
         </p:spPr>
       </p:sp>
       <p:sp>
@@ -14054,9 +14283,14 @@
             </a:avLst>
           </a:prstGeom>
           <a:solidFill>
-            <a:schemeClr val="tx1"/>
+            <a:schemeClr val="accent5"/>
           </a:solidFill>
-          <a:ln/>
+          <a:ln w="9525">
+            <a:solidFill>
+              <a:srgbClr val="B8C0CC"/>
+            </a:solidFill>
+            <a:prstDash val="solid"/>
+          </a:ln>
         </p:spPr>
       </p:sp>
       <p:pic>
@@ -14149,7 +14383,7 @@
             <a:r>
               <a:rPr lang="en-US" sz="1400" dirty="0">
                 <a:solidFill>
-                  <a:schemeClr val="bg1"/>
+                  <a:schemeClr val="tx1"/>
                 </a:solidFill>
               </a:rPr>
               <a:t>Your list has at least 6 items.</a:t>
@@ -14166,7 +14400,7 @@
             <a:r>
               <a:rPr lang="en-US" sz="1400" dirty="0">
                 <a:solidFill>
-                  <a:schemeClr val="bg1"/>
+                  <a:schemeClr val="tx1"/>
                 </a:solidFill>
               </a:rPr>
               <a:t>Every item is marked.</a:t>
@@ -14183,7 +14417,7 @@
             <a:r>
               <a:rPr lang="en-US" sz="1400" dirty="0">
                 <a:solidFill>
-                  <a:schemeClr val="bg1"/>
+                  <a:schemeClr val="tx1"/>
                 </a:solidFill>
               </a:rPr>
               <a:t>One item is circled, with a reason.</a:t>
@@ -14319,7 +14553,12 @@
           <a:solidFill>
             <a:schemeClr val="bg2"/>
           </a:solidFill>
-          <a:ln/>
+          <a:ln w="9525">
+            <a:solidFill>
+              <a:srgbClr val="B8C0CC"/>
+            </a:solidFill>
+            <a:prstDash val="solid"/>
+          </a:ln>
         </p:spPr>
       </p:sp>
       <p:sp>
@@ -14743,9 +14982,14 @@
             </a:avLst>
           </a:prstGeom>
           <a:solidFill>
-            <a:schemeClr val="tx1"/>
+            <a:schemeClr val="accent5"/>
           </a:solidFill>
-          <a:ln/>
+          <a:ln w="9525">
+            <a:solidFill>
+              <a:srgbClr val="B8C0CC"/>
+            </a:solidFill>
+            <a:prstDash val="solid"/>
+          </a:ln>
         </p:spPr>
       </p:sp>
       <p:pic>
@@ -14838,7 +15082,7 @@
             <a:r>
               <a:rPr lang="en-US" sz="1400" dirty="0">
                 <a:solidFill>
-                  <a:schemeClr val="bg1"/>
+                  <a:schemeClr val="tx1"/>
                 </a:solidFill>
               </a:rPr>
               <a:t>Context window question: answered, cites context-window.md.</a:t>
@@ -14855,7 +15099,7 @@
             <a:r>
               <a:rPr lang="en-US" sz="1400" dirty="0">
                 <a:solidFill>
-                  <a:schemeClr val="bg1"/>
+                  <a:schemeClr val="tx1"/>
                 </a:solidFill>
               </a:rPr>
               <a:t>"Wi-Fi password in Lab 3?" gets exactly:</a:t>
@@ -14872,7 +15116,7 @@
             <a:r>
               <a:rPr lang="en-US" sz="1400" b="1" dirty="0">
                 <a:solidFill>
-                  <a:schemeClr val="accent6"/>
+                  <a:schemeClr val="tx1"/>
                 </a:solidFill>
               </a:rPr>
               <a:t>not in the notes</a:t>
@@ -15008,7 +15252,12 @@
           <a:solidFill>
             <a:schemeClr val="bg2"/>
           </a:solidFill>
-          <a:ln/>
+          <a:ln w="9525">
+            <a:solidFill>
+              <a:srgbClr val="B8C0CC"/>
+            </a:solidFill>
+            <a:prstDash val="solid"/>
+          </a:ln>
         </p:spPr>
       </p:sp>
       <p:sp>
@@ -15432,9 +15681,14 @@
             </a:avLst>
           </a:prstGeom>
           <a:solidFill>
-            <a:schemeClr val="tx1"/>
+            <a:schemeClr val="accent5"/>
           </a:solidFill>
-          <a:ln/>
+          <a:ln w="9525">
+            <a:solidFill>
+              <a:srgbClr val="B8C0CC"/>
+            </a:solidFill>
+            <a:prstDash val="solid"/>
+          </a:ln>
         </p:spPr>
       </p:sp>
       <p:pic>
@@ -15527,7 +15781,7 @@
             <a:r>
               <a:rPr lang="en-US" sz="1400" dirty="0">
                 <a:solidFill>
-                  <a:schemeClr val="bg1"/>
+                  <a:schemeClr val="tx1"/>
                 </a:solidFill>
               </a:rPr>
               <a:t>It answers the Step 1 question.</a:t>
@@ -15544,7 +15798,7 @@
             <a:r>
               <a:rPr lang="en-US" sz="1400" dirty="0">
                 <a:solidFill>
-                  <a:schemeClr val="bg1"/>
+                  <a:schemeClr val="tx1"/>
                 </a:solidFill>
               </a:rPr>
               <a:t>You can list the code you deleted: loop, message list, tool dispatch, step counter.</a:t>
@@ -15700,7 +15954,7 @@
                       <a:r>
                         <a:rPr lang="en-US" sz="1400" b="1" dirty="0">
                           <a:solidFill>
-                            <a:schemeClr val="bg1"/>
+                            <a:schemeClr val="tx1"/>
                           </a:solidFill>
                         </a:rPr>
                         <a:t>#</a:t>
@@ -15746,7 +16000,7 @@
                       <a:tailEnd type="none" w="med" len="med"/>
                     </a:lnB>
                     <a:solidFill>
-                      <a:schemeClr val="tx1"/>
+                      <a:schemeClr val="accent1"/>
                     </a:solidFill>
                   </a:tcPr>
                 </a:tc>
@@ -15761,7 +16015,7 @@
                       <a:r>
                         <a:rPr lang="en-US" sz="1400" b="1" dirty="0">
                           <a:solidFill>
-                            <a:schemeClr val="bg1"/>
+                            <a:schemeClr val="tx1"/>
                           </a:solidFill>
                         </a:rPr>
                         <a:t>Guardrail</a:t>
@@ -15807,7 +16061,7 @@
                       <a:tailEnd type="none" w="med" len="med"/>
                     </a:lnB>
                     <a:solidFill>
-                      <a:schemeClr val="tx1"/>
+                      <a:schemeClr val="accent1"/>
                     </a:solidFill>
                   </a:tcPr>
                 </a:tc>
@@ -15822,7 +16076,7 @@
                       <a:r>
                         <a:rPr lang="en-US" sz="1400" b="1" dirty="0">
                           <a:solidFill>
-                            <a:schemeClr val="bg1"/>
+                            <a:schemeClr val="tx1"/>
                           </a:solidFill>
                         </a:rPr>
                         <a:t>How</a:t>
@@ -15868,7 +16122,7 @@
                       <a:tailEnd type="none" w="med" len="med"/>
                     </a:lnB>
                     <a:solidFill>
-                      <a:schemeClr val="tx1"/>
+                      <a:schemeClr val="accent1"/>
                     </a:solidFill>
                   </a:tcPr>
                 </a:tc>
@@ -16634,9 +16888,14 @@
             </a:avLst>
           </a:prstGeom>
           <a:solidFill>
-            <a:schemeClr val="tx1"/>
+            <a:schemeClr val="accent5"/>
           </a:solidFill>
-          <a:ln/>
+          <a:ln w="9525">
+            <a:solidFill>
+              <a:srgbClr val="B8C0CC"/>
+            </a:solidFill>
+            <a:prstDash val="solid"/>
+          </a:ln>
         </p:spPr>
       </p:sp>
       <p:pic>
@@ -16729,7 +16988,7 @@
             <a:r>
               <a:rPr lang="en-US" sz="1400" dirty="0">
                 <a:solidFill>
-                  <a:schemeClr val="bg1"/>
+                  <a:schemeClr val="tx1"/>
                 </a:solidFill>
               </a:rPr>
               <a:t>A 400-character task is blocked.</a:t>
@@ -16746,7 +17005,7 @@
             <a:r>
               <a:rPr lang="en-US" sz="1400" dirty="0">
                 <a:solidFill>
-                  <a:schemeClr val="bg1"/>
+                  <a:schemeClr val="tx1"/>
                 </a:solidFill>
               </a:rPr>
               <a:t>"Add: found a green scarf at Room 105" asks y/n. Answer n and items.json is unchanged.</a:t>
@@ -16763,7 +17022,7 @@
             <a:r>
               <a:rPr lang="en-US" sz="1400" dirty="0">
                 <a:solidFill>
-                  <a:schemeClr val="bg1"/>
+                  <a:schemeClr val="tx1"/>
                 </a:solidFill>
               </a:rPr>
               <a:t>Mehedi's contact number is never shown.</a:t>
@@ -16899,7 +17158,12 @@
           <a:solidFill>
             <a:schemeClr val="bg2"/>
           </a:solidFill>
-          <a:ln/>
+          <a:ln w="9525">
+            <a:solidFill>
+              <a:srgbClr val="B8C0CC"/>
+            </a:solidFill>
+            <a:prstDash val="solid"/>
+          </a:ln>
         </p:spPr>
       </p:sp>
       <p:sp>
@@ -17030,9 +17294,14 @@
             </a:avLst>
           </a:prstGeom>
           <a:solidFill>
-            <a:schemeClr val="tx1"/>
+            <a:schemeClr val="accent5"/>
           </a:solidFill>
-          <a:ln/>
+          <a:ln w="9525">
+            <a:solidFill>
+              <a:srgbClr val="B8C0CC"/>
+            </a:solidFill>
+            <a:prstDash val="solid"/>
+          </a:ln>
         </p:spPr>
       </p:sp>
       <p:sp>
@@ -17065,7 +17334,7 @@
             <a:r>
               <a:rPr lang="en-US" sz="1800" b="1" dirty="0">
                 <a:solidFill>
-                  <a:schemeClr val="accent6"/>
+                  <a:schemeClr val="tx1"/>
                 </a:solidFill>
               </a:rPr>
               <a:t>Show the instructor</a:t>
@@ -17083,7 +17352,7 @@
             <a:r>
               <a:rPr lang="en-US" sz="1500" dirty="0">
                 <a:solidFill>
-                  <a:schemeClr val="bg1"/>
+                  <a:schemeClr val="tx1"/>
                 </a:solidFill>
               </a:rPr>
               <a:t>Your Step 2 results table</a:t>
@@ -17101,7 +17370,7 @@
             <a:r>
               <a:rPr lang="en-US" sz="1500" dirty="0">
                 <a:solidFill>
-                  <a:schemeClr val="bg1"/>
+                  <a:schemeClr val="tx1"/>
                 </a:solidFill>
               </a:rPr>
               <a:t>A screenshot of Claude Code calling your MCP tool</a:t>
@@ -17119,7 +17388,7 @@
             <a:r>
               <a:rPr lang="en-US" sz="1500" dirty="0">
                 <a:solidFill>
-                  <a:schemeClr val="bg1"/>
+                  <a:schemeClr val="tx1"/>
                 </a:solidFill>
               </a:rPr>
               <a:t>Your Step 4 list, with the circled item</a:t>
@@ -17253,9 +17522,14 @@
             </a:avLst>
           </a:prstGeom>
           <a:solidFill>
-            <a:schemeClr val="tx1"/>
+            <a:schemeClr val="bg2"/>
           </a:solidFill>
-          <a:ln/>
+          <a:ln w="9525">
+            <a:solidFill>
+              <a:srgbClr val="B8C0CC"/>
+            </a:solidFill>
+            <a:prstDash val="solid"/>
+          </a:ln>
         </p:spPr>
       </p:sp>
       <p:sp>
@@ -17285,7 +17559,7 @@
             <a:r>
               <a:rPr lang="en-US" sz="1300" dirty="0">
                 <a:solidFill>
-                  <a:schemeClr val="bg1"/>
+                  <a:schemeClr val="tx1"/>
                 </a:solidFill>
                 <a:latin typeface="Courier New" pitchFamily="34" charset="0"/>
                 <a:ea typeface="Courier New" pitchFamily="34" charset="-122"/>
@@ -17302,7 +17576,7 @@
             <a:r>
               <a:rPr lang="en-US" sz="1300" dirty="0">
                 <a:solidFill>
-                  <a:schemeClr val="bg1"/>
+                  <a:schemeClr val="tx1"/>
                 </a:solidFill>
                 <a:latin typeface="Courier New" pitchFamily="34" charset="0"/>
                 <a:ea typeface="Courier New" pitchFamily="34" charset="-122"/>
@@ -17319,7 +17593,7 @@
             <a:r>
               <a:rPr lang="en-US" sz="1300" dirty="0">
                 <a:solidFill>
-                  <a:schemeClr val="bg1"/>
+                  <a:schemeClr val="tx1"/>
                 </a:solidFill>
                 <a:latin typeface="Courier New" pitchFamily="34" charset="0"/>
                 <a:ea typeface="Courier New" pitchFamily="34" charset="-122"/>
@@ -17336,7 +17610,7 @@
             <a:r>
               <a:rPr lang="en-US" sz="1300" dirty="0">
                 <a:solidFill>
-                  <a:schemeClr val="bg1"/>
+                  <a:schemeClr val="tx1"/>
                 </a:solidFill>
                 <a:latin typeface="Courier New" pitchFamily="34" charset="0"/>
                 <a:ea typeface="Courier New" pitchFamily="34" charset="-122"/>
@@ -17353,7 +17627,7 @@
             <a:r>
               <a:rPr lang="en-US" sz="1300" dirty="0">
                 <a:solidFill>
-                  <a:schemeClr val="bg1"/>
+                  <a:schemeClr val="tx1"/>
                 </a:solidFill>
                 <a:latin typeface="Courier New" pitchFamily="34" charset="0"/>
                 <a:ea typeface="Courier New" pitchFamily="34" charset="-122"/>
@@ -17420,7 +17694,12 @@
           <a:solidFill>
             <a:schemeClr val="bg2"/>
           </a:solidFill>
-          <a:ln/>
+          <a:ln w="9525">
+            <a:solidFill>
+              <a:srgbClr val="B8C0CC"/>
+            </a:solidFill>
+            <a:prstDash val="solid"/>
+          </a:ln>
         </p:spPr>
       </p:sp>
       <p:sp>
@@ -17438,7 +17717,7 @@
             <a:avLst/>
           </a:prstGeom>
           <a:solidFill>
-            <a:schemeClr val="tx1"/>
+            <a:schemeClr val="accent1"/>
           </a:solidFill>
           <a:ln/>
         </p:spPr>
@@ -17561,7 +17840,12 @@
           <a:solidFill>
             <a:schemeClr val="bg2"/>
           </a:solidFill>
-          <a:ln/>
+          <a:ln w="9525">
+            <a:solidFill>
+              <a:srgbClr val="B8C0CC"/>
+            </a:solidFill>
+            <a:prstDash val="solid"/>
+          </a:ln>
         </p:spPr>
       </p:sp>
       <p:sp>
@@ -17579,7 +17863,7 @@
             <a:avLst/>
           </a:prstGeom>
           <a:solidFill>
-            <a:schemeClr val="tx1"/>
+            <a:schemeClr val="accent1"/>
           </a:solidFill>
           <a:ln/>
         </p:spPr>
@@ -17702,7 +17986,12 @@
           <a:solidFill>
             <a:schemeClr val="bg2"/>
           </a:solidFill>
-          <a:ln/>
+          <a:ln w="9525">
+            <a:solidFill>
+              <a:srgbClr val="B8C0CC"/>
+            </a:solidFill>
+            <a:prstDash val="solid"/>
+          </a:ln>
         </p:spPr>
       </p:sp>
       <p:sp>
@@ -17720,7 +18009,7 @@
             <a:avLst/>
           </a:prstGeom>
           <a:solidFill>
-            <a:schemeClr val="tx1"/>
+            <a:srgbClr val="FBDDD3"/>
           </a:solidFill>
           <a:ln/>
         </p:spPr>
@@ -17987,7 +18276,12 @@
           <a:solidFill>
             <a:schemeClr val="bg2"/>
           </a:solidFill>
-          <a:ln/>
+          <a:ln w="9525">
+            <a:solidFill>
+              <a:srgbClr val="B8C0CC"/>
+            </a:solidFill>
+            <a:prstDash val="solid"/>
+          </a:ln>
         </p:spPr>
       </p:sp>
       <p:sp>
@@ -18069,7 +18363,12 @@
           <a:solidFill>
             <a:schemeClr val="bg2"/>
           </a:solidFill>
-          <a:ln/>
+          <a:ln w="9525">
+            <a:solidFill>
+              <a:srgbClr val="B8C0CC"/>
+            </a:solidFill>
+            <a:prstDash val="solid"/>
+          </a:ln>
         </p:spPr>
       </p:sp>
       <p:sp>
@@ -18151,7 +18450,12 @@
           <a:solidFill>
             <a:schemeClr val="accent1"/>
           </a:solidFill>
-          <a:ln/>
+          <a:ln w="9525">
+            <a:solidFill>
+              <a:srgbClr val="B8C0CC"/>
+            </a:solidFill>
+            <a:prstDash val="solid"/>
+          </a:ln>
         </p:spPr>
       </p:sp>
       <p:sp>
@@ -18247,7 +18551,12 @@
           <a:solidFill>
             <a:schemeClr val="bg2"/>
           </a:solidFill>
-          <a:ln/>
+          <a:ln w="9525">
+            <a:solidFill>
+              <a:srgbClr val="B8C0CC"/>
+            </a:solidFill>
+            <a:prstDash val="solid"/>
+          </a:ln>
         </p:spPr>
       </p:sp>
       <p:sp>
@@ -18341,7 +18650,12 @@
           <a:solidFill>
             <a:schemeClr val="bg2"/>
           </a:solidFill>
-          <a:ln/>
+          <a:ln w="9525">
+            <a:solidFill>
+              <a:srgbClr val="B8C0CC"/>
+            </a:solidFill>
+            <a:prstDash val="solid"/>
+          </a:ln>
         </p:spPr>
       </p:sp>
       <p:sp>
@@ -18413,7 +18727,12 @@
           <a:solidFill>
             <a:schemeClr val="bg2"/>
           </a:solidFill>
-          <a:ln/>
+          <a:ln w="9525">
+            <a:solidFill>
+              <a:srgbClr val="B8C0CC"/>
+            </a:solidFill>
+            <a:prstDash val="solid"/>
+          </a:ln>
         </p:spPr>
       </p:sp>
       <p:sp>
@@ -18591,9 +18910,14 @@
             </a:avLst>
           </a:prstGeom>
           <a:solidFill>
-            <a:schemeClr val="tx1"/>
+            <a:schemeClr val="bg2"/>
           </a:solidFill>
-          <a:ln/>
+          <a:ln w="9525">
+            <a:solidFill>
+              <a:srgbClr val="B8C0CC"/>
+            </a:solidFill>
+            <a:prstDash val="solid"/>
+          </a:ln>
         </p:spPr>
       </p:sp>
       <p:sp>
@@ -18623,7 +18947,7 @@
             <a:r>
               <a:rPr lang="en-US" sz="1200" dirty="0">
                 <a:solidFill>
-                  <a:schemeClr val="bg1"/>
+                  <a:schemeClr val="tx1"/>
                 </a:solidFill>
                 <a:latin typeface="Courier New" pitchFamily="34" charset="0"/>
                 <a:ea typeface="Courier New" pitchFamily="34" charset="-122"/>
@@ -18640,7 +18964,7 @@
             <a:r>
               <a:rPr lang="en-US" sz="1200" dirty="0">
                 <a:solidFill>
-                  <a:schemeClr val="bg1"/>
+                  <a:schemeClr val="tx1"/>
                 </a:solidFill>
                 <a:latin typeface="Courier New" pitchFamily="34" charset="0"/>
                 <a:ea typeface="Courier New" pitchFamily="34" charset="-122"/>
@@ -18657,7 +18981,7 @@
             <a:r>
               <a:rPr lang="en-US" sz="1200" dirty="0">
                 <a:solidFill>
-                  <a:schemeClr val="bg1"/>
+                  <a:schemeClr val="tx1"/>
                 </a:solidFill>
                 <a:latin typeface="Courier New" pitchFamily="34" charset="0"/>
                 <a:ea typeface="Courier New" pitchFamily="34" charset="-122"/>
@@ -18674,7 +18998,7 @@
             <a:r>
               <a:rPr lang="en-US" sz="1200" dirty="0">
                 <a:solidFill>
-                  <a:schemeClr val="bg1"/>
+                  <a:schemeClr val="tx1"/>
                 </a:solidFill>
                 <a:latin typeface="Courier New" pitchFamily="34" charset="0"/>
                 <a:ea typeface="Courier New" pitchFamily="34" charset="-122"/>
@@ -18691,7 +19015,7 @@
             <a:r>
               <a:rPr lang="en-US" sz="1200" dirty="0">
                 <a:solidFill>
-                  <a:schemeClr val="bg1"/>
+                  <a:schemeClr val="tx1"/>
                 </a:solidFill>
                 <a:latin typeface="Courier New" pitchFamily="34" charset="0"/>
                 <a:ea typeface="Courier New" pitchFamily="34" charset="-122"/>
@@ -18708,7 +19032,7 @@
             <a:r>
               <a:rPr lang="en-US" sz="1200" dirty="0">
                 <a:solidFill>
-                  <a:schemeClr val="bg1"/>
+                  <a:schemeClr val="tx1"/>
                 </a:solidFill>
                 <a:latin typeface="Courier New" pitchFamily="34" charset="0"/>
                 <a:ea typeface="Courier New" pitchFamily="34" charset="-122"/>
@@ -18725,7 +19049,7 @@
             <a:r>
               <a:rPr lang="en-US" sz="1200" dirty="0">
                 <a:solidFill>
-                  <a:schemeClr val="bg1"/>
+                  <a:schemeClr val="tx1"/>
                 </a:solidFill>
                 <a:latin typeface="Courier New" pitchFamily="34" charset="0"/>
                 <a:ea typeface="Courier New" pitchFamily="34" charset="-122"/>
@@ -18742,7 +19066,7 @@
             <a:r>
               <a:rPr lang="en-US" sz="1200" dirty="0">
                 <a:solidFill>
-                  <a:schemeClr val="bg1"/>
+                  <a:schemeClr val="tx1"/>
                 </a:solidFill>
                 <a:latin typeface="Courier New" pitchFamily="34" charset="0"/>
                 <a:ea typeface="Courier New" pitchFamily="34" charset="-122"/>
@@ -18782,7 +19106,7 @@
             <a:r>
               <a:rPr lang="en-US" sz="1200" dirty="0">
                 <a:solidFill>
-                  <a:schemeClr val="bg1"/>
+                  <a:schemeClr val="tx1"/>
                 </a:solidFill>
                 <a:latin typeface="Courier New" pitchFamily="34" charset="0"/>
                 <a:ea typeface="Courier New" pitchFamily="34" charset="-122"/>
@@ -18799,7 +19123,7 @@
             <a:r>
               <a:rPr lang="en-US" sz="1200" dirty="0">
                 <a:solidFill>
-                  <a:schemeClr val="bg1"/>
+                  <a:schemeClr val="tx1"/>
                 </a:solidFill>
                 <a:latin typeface="Courier New" pitchFamily="34" charset="0"/>
                 <a:ea typeface="Courier New" pitchFamily="34" charset="-122"/>
@@ -18816,7 +19140,7 @@
             <a:r>
               <a:rPr lang="en-US" sz="1200" dirty="0">
                 <a:solidFill>
-                  <a:schemeClr val="bg1"/>
+                  <a:schemeClr val="tx1"/>
                 </a:solidFill>
                 <a:latin typeface="Courier New" pitchFamily="34" charset="0"/>
                 <a:ea typeface="Courier New" pitchFamily="34" charset="-122"/>
@@ -19121,9 +19445,14 @@
             </a:avLst>
           </a:prstGeom>
           <a:solidFill>
-            <a:schemeClr val="tx1"/>
+            <a:schemeClr val="accent6"/>
           </a:solidFill>
-          <a:ln/>
+          <a:ln w="9525">
+            <a:solidFill>
+              <a:srgbClr val="B8C0CC"/>
+            </a:solidFill>
+            <a:prstDash val="solid"/>
+          </a:ln>
         </p:spPr>
       </p:sp>
       <p:sp>
@@ -19209,9 +19538,9 @@
               <a:buNone/>
             </a:pPr>
             <a:r>
-              <a:rPr lang="en-US" sz="1200" dirty="0">
-                <a:solidFill>
-                  <a:schemeClr val="bg1"/>
+              <a:rPr lang="en-US" sz="1200" b="1" dirty="0">
+                <a:solidFill>
+                  <a:schemeClr val="tx1"/>
                 </a:solidFill>
                 <a:latin typeface="Courier New" pitchFamily="34" charset="0"/>
                 <a:ea typeface="Courier New" pitchFamily="34" charset="-122"/>
@@ -19350,7 +19679,12 @@
           <a:solidFill>
             <a:schemeClr val="bg2"/>
           </a:solidFill>
-          <a:ln/>
+          <a:ln w="9525">
+            <a:solidFill>
+              <a:srgbClr val="B8C0CC"/>
+            </a:solidFill>
+            <a:prstDash val="solid"/>
+          </a:ln>
         </p:spPr>
       </p:sp>
       <p:sp>
@@ -19368,7 +19702,7 @@
             <a:avLst/>
           </a:prstGeom>
           <a:solidFill>
-            <a:schemeClr val="tx1"/>
+            <a:schemeClr val="accent1"/>
           </a:solidFill>
           <a:ln/>
         </p:spPr>
@@ -19571,7 +19905,12 @@
           <a:solidFill>
             <a:schemeClr val="bg2"/>
           </a:solidFill>
-          <a:ln/>
+          <a:ln w="9525">
+            <a:solidFill>
+              <a:srgbClr val="B8C0CC"/>
+            </a:solidFill>
+            <a:prstDash val="solid"/>
+          </a:ln>
         </p:spPr>
       </p:sp>
       <p:sp>
@@ -19589,7 +19928,7 @@
             <a:avLst/>
           </a:prstGeom>
           <a:solidFill>
-            <a:schemeClr val="tx1"/>
+            <a:schemeClr val="accent1"/>
           </a:solidFill>
           <a:ln/>
         </p:spPr>
@@ -19792,7 +20131,12 @@
           <a:solidFill>
             <a:schemeClr val="bg2"/>
           </a:solidFill>
-          <a:ln/>
+          <a:ln w="9525">
+            <a:solidFill>
+              <a:srgbClr val="B8C0CC"/>
+            </a:solidFill>
+            <a:prstDash val="solid"/>
+          </a:ln>
         </p:spPr>
       </p:sp>
       <p:sp>
@@ -19810,7 +20154,7 @@
             <a:avLst/>
           </a:prstGeom>
           <a:solidFill>
-            <a:schemeClr val="tx1"/>
+            <a:schemeClr val="accent1"/>
           </a:solidFill>
           <a:ln/>
         </p:spPr>
@@ -20142,7 +20486,7 @@
                       <a:r>
                         <a:rPr lang="en-US" sz="1400" b="1" dirty="0">
                           <a:solidFill>
-                            <a:schemeClr val="bg1"/>
+                            <a:schemeClr val="tx1"/>
                           </a:solidFill>
                         </a:rPr>
                         <a:t>Pattern</a:t>
@@ -20188,7 +20532,7 @@
                       <a:tailEnd type="none" w="med" len="med"/>
                     </a:lnB>
                     <a:solidFill>
-                      <a:schemeClr val="tx1"/>
+                      <a:schemeClr val="accent1"/>
                     </a:solidFill>
                   </a:tcPr>
                 </a:tc>
@@ -20203,7 +20547,7 @@
                       <a:r>
                         <a:rPr lang="en-US" sz="1400" b="1" dirty="0">
                           <a:solidFill>
-                            <a:schemeClr val="bg1"/>
+                            <a:schemeClr val="tx1"/>
                           </a:solidFill>
                         </a:rPr>
                         <a:t>Extra calls</a:t>
@@ -20249,7 +20593,7 @@
                       <a:tailEnd type="none" w="med" len="med"/>
                     </a:lnB>
                     <a:solidFill>
-                      <a:schemeClr val="tx1"/>
+                      <a:schemeClr val="accent1"/>
                     </a:solidFill>
                   </a:tcPr>
                 </a:tc>
@@ -20264,7 +20608,7 @@
                       <a:r>
                         <a:rPr lang="en-US" sz="1400" b="1" dirty="0">
                           <a:solidFill>
-                            <a:schemeClr val="bg1"/>
+                            <a:schemeClr val="tx1"/>
                           </a:solidFill>
                         </a:rPr>
                         <a:t>Helps with</a:t>
@@ -20310,7 +20654,7 @@
                       <a:tailEnd type="none" w="med" len="med"/>
                     </a:lnB>
                     <a:solidFill>
-                      <a:schemeClr val="tx1"/>
+                      <a:schemeClr val="accent1"/>
                     </a:solidFill>
                   </a:tcPr>
                 </a:tc>
@@ -20325,7 +20669,7 @@
                       <a:r>
                         <a:rPr lang="en-US" sz="1400" b="1" dirty="0">
                           <a:solidFill>
-                            <a:schemeClr val="bg1"/>
+                            <a:schemeClr val="tx1"/>
                           </a:solidFill>
                         </a:rPr>
                         <a:t>Watch out</a:t>
@@ -20371,7 +20715,7 @@
                       <a:tailEnd type="none" w="med" len="med"/>
                     </a:lnB>
                     <a:solidFill>
-                      <a:schemeClr val="tx1"/>
+                      <a:schemeClr val="accent1"/>
                     </a:solidFill>
                   </a:tcPr>
                 </a:tc>
@@ -21171,9 +21515,14 @@
             </a:avLst>
           </a:prstGeom>
           <a:solidFill>
-            <a:schemeClr val="tx1"/>
+            <a:schemeClr val="accent6"/>
           </a:solidFill>
-          <a:ln/>
+          <a:ln w="9525">
+            <a:solidFill>
+              <a:srgbClr val="B8C0CC"/>
+            </a:solidFill>
+            <a:prstDash val="solid"/>
+          </a:ln>
         </p:spPr>
       </p:sp>
       <p:sp>
@@ -21259,9 +21608,9 @@
               <a:buNone/>
             </a:pPr>
             <a:r>
-              <a:rPr lang="en-US" sz="1200" dirty="0">
-                <a:solidFill>
-                  <a:schemeClr val="bg1"/>
+              <a:rPr lang="en-US" sz="1200" b="1" dirty="0">
+                <a:solidFill>
+                  <a:schemeClr val="tx1"/>
                 </a:solidFill>
                 <a:latin typeface="Courier New" pitchFamily="34" charset="0"/>
                 <a:ea typeface="Courier New" pitchFamily="34" charset="-122"/>
@@ -21470,7 +21819,7 @@
           <a:noFill/>
           <a:ln w="12700">
             <a:solidFill>
-              <a:schemeClr val="accent5"/>
+              <a:srgbClr val="8A94A6"/>
             </a:solidFill>
             <a:prstDash val="solid"/>
           </a:ln>
@@ -21493,7 +21842,7 @@
           <a:noFill/>
           <a:ln w="12700">
             <a:solidFill>
-              <a:schemeClr val="accent5"/>
+              <a:srgbClr val="8A94A6"/>
             </a:solidFill>
             <a:prstDash val="solid"/>
           </a:ln>
@@ -21516,7 +21865,7 @@
           <a:noFill/>
           <a:ln w="12700">
             <a:solidFill>
-              <a:schemeClr val="accent5"/>
+              <a:srgbClr val="8A94A6"/>
             </a:solidFill>
             <a:prstDash val="solid"/>
           </a:ln>
@@ -21539,7 +21888,7 @@
           <a:noFill/>
           <a:ln w="12700">
             <a:solidFill>
-              <a:schemeClr val="accent5"/>
+              <a:srgbClr val="8A94A6"/>
             </a:solidFill>
             <a:prstDash val="solid"/>
           </a:ln>
@@ -21562,7 +21911,7 @@
           <a:noFill/>
           <a:ln w="12700">
             <a:solidFill>
-              <a:schemeClr val="accent5"/>
+              <a:srgbClr val="8A94A6"/>
             </a:solidFill>
             <a:prstDash val="solid"/>
           </a:ln>
@@ -21585,7 +21934,7 @@
           <a:noFill/>
           <a:ln w="12700">
             <a:solidFill>
-              <a:schemeClr val="accent5"/>
+              <a:srgbClr val="8A94A6"/>
             </a:solidFill>
             <a:prstDash val="solid"/>
           </a:ln>
@@ -21608,7 +21957,7 @@
           <a:noFill/>
           <a:ln w="12700">
             <a:solidFill>
-              <a:schemeClr val="accent5"/>
+              <a:srgbClr val="8A94A6"/>
             </a:solidFill>
             <a:prstDash val="solid"/>
           </a:ln>
@@ -21631,7 +21980,7 @@
           <a:noFill/>
           <a:ln w="12700">
             <a:solidFill>
-              <a:schemeClr val="accent5"/>
+              <a:srgbClr val="8A94A6"/>
             </a:solidFill>
             <a:prstDash val="solid"/>
           </a:ln>
@@ -21654,7 +22003,7 @@
           <a:noFill/>
           <a:ln w="12700">
             <a:solidFill>
-              <a:schemeClr val="accent5"/>
+              <a:srgbClr val="8A94A6"/>
             </a:solidFill>
             <a:prstDash val="solid"/>
           </a:ln>
@@ -22711,9 +23060,14 @@
             </a:avLst>
           </a:prstGeom>
           <a:solidFill>
-            <a:schemeClr val="tx1"/>
+            <a:schemeClr val="bg2"/>
           </a:solidFill>
-          <a:ln/>
+          <a:ln w="9525">
+            <a:solidFill>
+              <a:srgbClr val="B8C0CC"/>
+            </a:solidFill>
+            <a:prstDash val="solid"/>
+          </a:ln>
         </p:spPr>
       </p:sp>
       <p:sp>
@@ -22743,7 +23097,7 @@
             <a:r>
               <a:rPr lang="en-US" sz="1200" dirty="0">
                 <a:solidFill>
-                  <a:schemeClr val="bg1"/>
+                  <a:schemeClr val="tx1"/>
                 </a:solidFill>
                 <a:latin typeface="Courier New" pitchFamily="34" charset="0"/>
                 <a:ea typeface="Courier New" pitchFamily="34" charset="-122"/>
@@ -22760,7 +23114,7 @@
             <a:r>
               <a:rPr lang="en-US" sz="1200" dirty="0">
                 <a:solidFill>
-                  <a:schemeClr val="bg1"/>
+                  <a:schemeClr val="tx1"/>
                 </a:solidFill>
                 <a:latin typeface="Courier New" pitchFamily="34" charset="0"/>
                 <a:ea typeface="Courier New" pitchFamily="34" charset="-122"/>
@@ -22783,7 +23137,7 @@
             <a:r>
               <a:rPr lang="en-US" sz="1200" dirty="0">
                 <a:solidFill>
-                  <a:schemeClr val="bg1"/>
+                  <a:schemeClr val="tx1"/>
                 </a:solidFill>
                 <a:latin typeface="Courier New" pitchFamily="34" charset="0"/>
                 <a:ea typeface="Courier New" pitchFamily="34" charset="-122"/>
@@ -22800,7 +23154,7 @@
             <a:r>
               <a:rPr lang="en-US" sz="1200" dirty="0">
                 <a:solidFill>
-                  <a:schemeClr val="bg1"/>
+                  <a:schemeClr val="tx1"/>
                 </a:solidFill>
                 <a:latin typeface="Courier New" pitchFamily="34" charset="0"/>
                 <a:ea typeface="Courier New" pitchFamily="34" charset="-122"/>
@@ -22817,7 +23171,7 @@
             <a:r>
               <a:rPr lang="en-US" sz="1200" dirty="0">
                 <a:solidFill>
-                  <a:schemeClr val="bg1"/>
+                  <a:schemeClr val="tx1"/>
                 </a:solidFill>
                 <a:latin typeface="Courier New" pitchFamily="34" charset="0"/>
                 <a:ea typeface="Courier New" pitchFamily="34" charset="-122"/>
@@ -22834,7 +23188,7 @@
             <a:r>
               <a:rPr lang="en-US" sz="1200" dirty="0">
                 <a:solidFill>
-                  <a:schemeClr val="bg1"/>
+                  <a:schemeClr val="tx1"/>
                 </a:solidFill>
                 <a:latin typeface="Courier New" pitchFamily="34" charset="0"/>
                 <a:ea typeface="Courier New" pitchFamily="34" charset="-122"/>
@@ -22851,7 +23205,7 @@
             <a:r>
               <a:rPr lang="en-US" sz="1200" dirty="0">
                 <a:solidFill>
-                  <a:schemeClr val="bg1"/>
+                  <a:schemeClr val="tx1"/>
                 </a:solidFill>
                 <a:latin typeface="Courier New" pitchFamily="34" charset="0"/>
                 <a:ea typeface="Courier New" pitchFamily="34" charset="-122"/>
@@ -22868,7 +23222,7 @@
             <a:r>
               <a:rPr lang="en-US" sz="1200" dirty="0">
                 <a:solidFill>
-                  <a:schemeClr val="bg1"/>
+                  <a:schemeClr val="tx1"/>
                 </a:solidFill>
                 <a:latin typeface="Courier New" pitchFamily="34" charset="0"/>
                 <a:ea typeface="Courier New" pitchFamily="34" charset="-122"/>
@@ -22885,7 +23239,7 @@
             <a:r>
               <a:rPr lang="en-US" sz="1200" dirty="0">
                 <a:solidFill>
-                  <a:schemeClr val="bg1"/>
+                  <a:schemeClr val="tx1"/>
                 </a:solidFill>
                 <a:latin typeface="Courier New" pitchFamily="34" charset="0"/>
                 <a:ea typeface="Courier New" pitchFamily="34" charset="-122"/>
@@ -22908,7 +23262,7 @@
             <a:r>
               <a:rPr lang="en-US" sz="1200" dirty="0">
                 <a:solidFill>
-                  <a:schemeClr val="bg1"/>
+                  <a:schemeClr val="tx1"/>
                 </a:solidFill>
                 <a:latin typeface="Courier New" pitchFamily="34" charset="0"/>
                 <a:ea typeface="Courier New" pitchFamily="34" charset="-122"/>
@@ -22939,7 +23293,12 @@
           <a:solidFill>
             <a:schemeClr val="bg2"/>
           </a:solidFill>
-          <a:ln/>
+          <a:ln w="9525">
+            <a:solidFill>
+              <a:srgbClr val="B8C0CC"/>
+            </a:solidFill>
+            <a:prstDash val="solid"/>
+          </a:ln>
         </p:spPr>
       </p:sp>
       <p:sp>
@@ -22957,7 +23316,7 @@
             <a:avLst/>
           </a:prstGeom>
           <a:solidFill>
-            <a:schemeClr val="tx1"/>
+            <a:schemeClr val="accent1"/>
           </a:solidFill>
           <a:ln/>
         </p:spPr>
@@ -23041,7 +23400,12 @@
           <a:solidFill>
             <a:schemeClr val="bg2"/>
           </a:solidFill>
-          <a:ln/>
+          <a:ln w="9525">
+            <a:solidFill>
+              <a:srgbClr val="B8C0CC"/>
+            </a:solidFill>
+            <a:prstDash val="solid"/>
+          </a:ln>
         </p:spPr>
       </p:sp>
       <p:sp>
@@ -23059,7 +23423,7 @@
             <a:avLst/>
           </a:prstGeom>
           <a:solidFill>
-            <a:schemeClr val="tx1"/>
+            <a:srgbClr val="FBDDD3"/>
           </a:solidFill>
           <a:ln/>
         </p:spPr>
@@ -23141,9 +23505,14 @@
             </a:avLst>
           </a:prstGeom>
           <a:solidFill>
-            <a:schemeClr val="tx1"/>
+            <a:schemeClr val="accent6"/>
           </a:solidFill>
-          <a:ln/>
+          <a:ln w="9525">
+            <a:solidFill>
+              <a:srgbClr val="B8C0CC"/>
+            </a:solidFill>
+            <a:prstDash val="solid"/>
+          </a:ln>
         </p:spPr>
       </p:sp>
       <p:sp>
@@ -23229,9 +23598,9 @@
               <a:buNone/>
             </a:pPr>
             <a:r>
-              <a:rPr lang="en-US" sz="1200" dirty="0">
-                <a:solidFill>
-                  <a:schemeClr val="bg1"/>
+              <a:rPr lang="en-US" sz="1200" b="1" dirty="0">
+                <a:solidFill>
+                  <a:schemeClr val="tx1"/>
                 </a:solidFill>
                 <a:latin typeface="Courier New" pitchFamily="34" charset="0"/>
                 <a:ea typeface="Courier New" pitchFamily="34" charset="-122"/>
@@ -23310,31 +23679,31 @@
         <a:srgbClr val="2B2D36"/>
       </a:dk2>
       <a:lt2>
-        <a:srgbClr val="F1F3F5"/>
+        <a:srgbClr val="E8ECF1"/>
       </a:lt2>
       <a:accent1>
         <a:srgbClr val="F4A300"/>
       </a:accent1>
       <a:accent2>
-        <a:srgbClr val="1FB5A8"/>
+        <a:srgbClr val="0B6E66"/>
       </a:accent2>
       <a:accent3>
-        <a:srgbClr val="E4572E"/>
+        <a:srgbClr val="C23B1A"/>
       </a:accent3>
       <a:accent4>
-        <a:srgbClr val="5B6472"/>
+        <a:srgbClr val="404955"/>
       </a:accent4>
       <a:accent5>
-        <a:srgbClr val="AAB2C0"/>
+        <a:srgbClr val="DDF3F0"/>
       </a:accent5>
       <a:accent6>
-        <a:srgbClr val="FFD166"/>
+        <a:srgbClr val="FFF1CC"/>
       </a:accent6>
       <a:hlink>
-        <a:srgbClr val="1FB5A8"/>
+        <a:srgbClr val="0B6E66"/>
       </a:hlink>
       <a:folHlink>
-        <a:srgbClr val="5B6472"/>
+        <a:srgbClr val="404955"/>
       </a:folHlink>
     </a:clrScheme>
     <a:fontScheme name="Lost and Found">

</xml_diff>